<commit_message>
feat(security & admin): NIST PBKDF2 password hashing with legacy migration, patient CRUD, and schedule management
</commit_message>
<xml_diff>
--- a/presentation/Clinic_Appointment_Management_System_Presentation.pptx
+++ b/presentation/Clinic_Appointment_Management_System_Presentation.pptx
@@ -4432,7 +4432,7 @@
               </a:defRPr>
             </a:pPr>
             <a:r>
-              <a:t>✔ Security: Salted SHA-256 password hashing for administrators, JWT Bearer tokens with Claims-based authorization, and protected Angular route guards.</a:t>
+              <a:t>✔ Security: PBKDF2 password hashing (100k iterations, 128-bit salt), transparent legacy migration, JWT Bearer tokens, and protected Angular route guards.</a:t>
             </a:r>
           </a:p>
           <a:p>
@@ -6220,7 +6220,7 @@
               </a:defRPr>
             </a:pPr>
             <a:r>
-              <a:t>• Salted SHA-256 password hashing logic</a:t>
+              <a:t>• PBKDF2 PasswordSecurity (100k iterations, random 128-bit salt)</a:t>
             </a:r>
           </a:p>
           <a:p>
@@ -7189,7 +7189,7 @@
               </a:defRPr>
             </a:pPr>
             <a:r>
-              <a:t>• Doctor Management: Add new doctors, update consultation fees, configure working hours and generate available slots.</a:t>
+              <a:t>• Doctor &amp; Schedule Management: Full doctor CRUD, consultation fees, weekly working hours editing, and slot availability toggles.</a:t>
             </a:r>
           </a:p>
           <a:p>
@@ -7219,7 +7219,7 @@
               </a:defRPr>
             </a:pPr>
             <a:r>
-              <a:t>• Patient Directory: Searchable patient registry displaying complete appointment histories.</a:t>
+              <a:t>• Patient Directory &amp; Management: Searchable patient registry, detail view, patient record editing, and safe deletion.</a:t>
             </a:r>
           </a:p>
           <a:p>

</xml_diff>